<commit_message>
docs: sync official SIH26105 team registration details (ByteForce_1, Team ID 180219, SIET Greater Noida)
</commit_message>
<xml_diff>
--- a/Docs/AURA_SENTINEL_SIH26105.pptx
+++ b/Docs/AURA_SENTINEL_SIH26105.pptx
@@ -3227,6 +3227,66 @@
               </a:defRPr>
             </a:pPr>
             <a:r>
+              <a:t>• Team Name &amp; ID: </a:t>
+            </a:r>
+            <a:r>
+              <a:rPr b="0">
+                <a:solidFill>
+                  <a:srgbClr val="F1F5F9"/>
+                </a:solidFill>
+              </a:rPr>
+              <a:t>ByteForce_1 (Official SIH Team ID: 180219)</a:t>
+            </a:r>
+          </a:p>
+          <a:p>
+            <a:pPr>
+              <a:defRPr sz="1200" b="1">
+                <a:solidFill>
+                  <a:srgbClr val="FBBF24"/>
+                </a:solidFill>
+              </a:defRPr>
+            </a:pPr>
+            <a:r>
+              <a:t>• College / Institute: </a:t>
+            </a:r>
+            <a:r>
+              <a:rPr b="0">
+                <a:solidFill>
+                  <a:srgbClr val="F1F5F9"/>
+                </a:solidFill>
+              </a:rPr>
+              <a:t>Skyline Institute of Engineering and Technology, Greater Noida</a:t>
+            </a:r>
+          </a:p>
+          <a:p>
+            <a:pPr>
+              <a:defRPr sz="1200" b="1">
+                <a:solidFill>
+                  <a:srgbClr val="FBBF24"/>
+                </a:solidFill>
+              </a:defRPr>
+            </a:pPr>
+            <a:r>
+              <a:t>• Team Leader &amp; Members: </a:t>
+            </a:r>
+            <a:r>
+              <a:rPr b="0">
+                <a:solidFill>
+                  <a:srgbClr val="F1F5F9"/>
+                </a:solidFill>
+              </a:rPr>
+              <a:t>Aryan Baghel (Lead), Kirti, Hitesh Chauhan, Avinav Jha, Sharim Khan, Aman Sekh</a:t>
+            </a:r>
+          </a:p>
+          <a:p>
+            <a:pPr>
+              <a:defRPr sz="1200" b="1">
+                <a:solidFill>
+                  <a:srgbClr val="FBBF24"/>
+                </a:solidFill>
+              </a:defRPr>
+            </a:pPr>
+            <a:r>
               <a:t>• Problem Statement ID: </a:t>
             </a:r>
             <a:r>
@@ -3235,7 +3295,7 @@
                   <a:srgbClr val="F1F5F9"/>
                 </a:solidFill>
               </a:rPr>
-              <a:t>SIH26105</a:t>
+              <a:t>SIH26105 (AICTE Cyber Security Cell)</a:t>
             </a:r>
           </a:p>
           <a:p>
@@ -3247,7 +3307,7 @@
               </a:defRPr>
             </a:pPr>
             <a:r>
-              <a:t>• Theme: </a:t>
+              <a:t>• Theme &amp; Category: </a:t>
             </a:r>
             <a:r>
               <a:rPr b="0">
@@ -3255,47 +3315,7 @@
                   <a:srgbClr val="F1F5F9"/>
                 </a:solidFill>
               </a:rPr>
-              <a:t>Blockchain &amp; Cybersecurity</a:t>
-            </a:r>
-          </a:p>
-          <a:p>
-            <a:pPr>
-              <a:defRPr sz="1200" b="1">
-                <a:solidFill>
-                  <a:srgbClr val="FBBF24"/>
-                </a:solidFill>
-              </a:defRPr>
-            </a:pPr>
-            <a:r>
-              <a:t>• Target Organization: </a:t>
-            </a:r>
-            <a:r>
-              <a:rPr b="0">
-                <a:solidFill>
-                  <a:srgbClr val="F1F5F9"/>
-                </a:solidFill>
-              </a:rPr>
-              <a:t>All India Council for Technical Education (AICTE - Cyber Security Cell)</a:t>
-            </a:r>
-          </a:p>
-          <a:p>
-            <a:pPr>
-              <a:defRPr sz="1200" b="1">
-                <a:solidFill>
-                  <a:srgbClr val="FBBF24"/>
-                </a:solidFill>
-              </a:defRPr>
-            </a:pPr>
-            <a:r>
-              <a:t>• Category &amp; Domain: </a:t>
-            </a:r>
-            <a:r>
-              <a:rPr b="0">
-                <a:solidFill>
-                  <a:srgbClr val="F1F5F9"/>
-                </a:solidFill>
-              </a:rPr>
-              <a:t>Enterprise &amp; Higher Education Cyber Defense (Software)</a:t>
+              <a:t>Blockchain &amp; Cybersecurity (Software - Enterprise Defense)</a:t>
             </a:r>
           </a:p>
           <a:p>

</xml_diff>

<commit_message>
docs: align presentation deck with official AICTE SIH26105 description (RBI/SEBI/ISO27001/VaR/Pareto)
</commit_message>
<xml_diff>
--- a/Docs/AURA_SENTINEL_SIH26105.pptx
+++ b/Docs/AURA_SENTINEL_SIH26105.pptx
@@ -4601,7 +4601,7 @@
               </a:defRPr>
             </a:pPr>
             <a:r>
-              <a:t>EAL (₹) = TEF × Vulnerability Factor × Loss Magnitude (₹)</a:t>
+              <a:t>EAL (₹) = TEF × Vulnerability Factor × Loss Magnitude (₹) | Value at Risk (VaR 95%)</a:t>
             </a:r>
             <a:br/>
             <a:r>
@@ -4617,7 +4617,7 @@
               </a:defRPr>
             </a:pPr>
             <a:r>
-              <a:t>Replaces unquantified CVE severity scores with definitive INR liability figures understood by institutional finance heads.</a:t>
+              <a:t>Replaces unquantified CVE scores with definitive INR liability &amp; Value at Risk (VaR) figures understood by CFOs/Directors.</a:t>
             </a:r>
           </a:p>
         </p:txBody>
@@ -4690,7 +4690,7 @@
             </a:r>
             <a:br/>
             <a:r>
-              <a:t>Constraint: Σ(Solution Costs) ≤ Total Budget (₹)</a:t>
+              <a:t>Budget Constraint: Σ(Costs) ≤ Institutional Budget (e.g. ₹1 Crore)</a:t>
             </a:r>
           </a:p>
           <a:p>
@@ -4702,7 +4702,7 @@
               </a:defRPr>
             </a:pPr>
             <a:r>
-              <a:t>Dynamic programming formulation yields the Pareto-optimal defense deployment for any given institutional budget.</a:t>
+              <a:t>Dynamic programming Pareto frontier reveals diminishing returns &amp; optimal spend zones for board-level decisions.</a:t>
             </a:r>
           </a:p>
         </p:txBody>
@@ -5489,7 +5489,7 @@
               </a:defRPr>
             </a:pPr>
             <a:r>
-              <a:t>📜 CERT-In Cyber Security Directions (April 2022):</a:t>
+              <a:t>📜 RBI &amp; SEBI Cyber Resilience Frameworks:</a:t>
             </a:r>
             <a:br/>
             <a:r>
@@ -5501,7 +5501,7 @@
                   <a:srgbClr val="94A3B8"/>
                 </a:solidFill>
               </a:rPr>
-              <a:t>Mandates strict preservation of cyber incident logs for 180 days. AURA's blockchain ledger guarantees immutable, un-erasable compliance.</a:t>
+              <a:t>Native regulatory control mapping, risk threshold alerting, and board-level risk posture reporting.</a:t>
             </a:r>
           </a:p>
           <a:p>
@@ -5516,7 +5516,7 @@
               </a:defRPr>
             </a:pPr>
             <a:r>
-              <a:t>📜 Digital Personal Data Protection (DPDP) Act 2023:</a:t>
+              <a:t>📜 ISO/IEC 27001 &amp; NIST CSF 2.0 &amp; CIS Controls:</a:t>
             </a:r>
             <a:br/>
             <a:r>
@@ -5528,7 +5528,7 @@
                   <a:srgbClr val="94A3B8"/>
                 </a:solidFill>
               </a:rPr>
-              <a:t>Built-in sensitive scanner identifies unmasked Aadhaar, PAN numbers, and API credentials to avert massive regulatory fines.</a:t>
+              <a:t>Automated evidence aggregation across Identify, Protect, Detect, Respond, Recover functions.</a:t>
             </a:r>
           </a:p>
           <a:p>
@@ -5543,7 +5543,7 @@
               </a:defRPr>
             </a:pPr>
             <a:r>
-              <a:t>📜 NIST Cybersecurity Framework 2.0:</a:t>
+              <a:t>📜 CERT-In Directions (April 2022) &amp; DPDP Act 2023:</a:t>
             </a:r>
             <a:br/>
             <a:r>
@@ -5555,7 +5555,7 @@
                   <a:srgbClr val="94A3B8"/>
                 </a:solidFill>
               </a:rPr>
-              <a:t>Comprehensive mapping to all 5 core functions: Identify, Protect, Detect, Respond, Recover.</a:t>
+              <a:t>Mandatory 180-day unalterable incident log retention via SHA-256 Merkle blockchain + Indian PII protection.</a:t>
             </a:r>
           </a:p>
           <a:p>
@@ -5570,7 +5570,7 @@
               </a:defRPr>
             </a:pPr>
             <a:r>
-              <a:t>📜 MITRE ATT&amp;CK Matrix v15:</a:t>
+              <a:t>📜 MITRE ATT&amp;CK Matrix v15 &amp; What-If Simulations:</a:t>
             </a:r>
             <a:br/>
             <a:r>
@@ -5582,7 +5582,7 @@
                   <a:srgbClr val="94A3B8"/>
                 </a:solidFill>
               </a:rPr>
-              <a:t>Real-time wargame attack simulation across brute force, port scans, and reverse shell vulnerabilities.</a:t>
+              <a:t>Real-time threat actor TTP mappings &amp; scenario modeling (e.g. MFA deployment vs 30-day patch delay).</a:t>
             </a:r>
           </a:p>
         </p:txBody>

</xml_diff>